<commit_message>
docs: finalize Phase 2 presentation package
</commit_message>
<xml_diff>
--- a/docs/MembersPlan/InsightFlow-Phase-2-Elite.pptx
+++ b/docs/MembersPlan/InsightFlow-Phase-2-Elite.pptx
@@ -2828,7 +2828,7 @@
               </a:defRPr>
             </a:pPr>
             <a:r>
-              <a:rPr sz="5250" b="1">
+              <a:rPr sz="5250" b="1" dirty="0">
                 <a:solidFill>
                   <a:srgbClr val="2C5F5B"/>
                 </a:solidFill>
@@ -2878,7 +2878,7 @@
               </a:defRPr>
             </a:pPr>
             <a:r>
-              <a:rPr sz="4050" b="0">
+              <a:rPr sz="4050" b="0" dirty="0">
                 <a:solidFill>
                   <a:srgbClr val="1FC7B9"/>
                 </a:solidFill>
@@ -3179,18 +3179,269 @@
   <p:clrMapOvr>
     <a:masterClrMapping/>
   </p:clrMapOvr>
-  <mc:AlternateContent xmlns:mc="http://schemas.openxmlformats.org/markup-compatibility/2006">
-    <mc:Choice xmlns:p159="http://schemas.microsoft.com/office/powerpoint/2015/09/main" Requires="p159">
+  <mc:AlternateContent xmlns:mc="http://schemas.openxmlformats.org/markup-compatibility/2006" xmlns:p159="http://schemas.microsoft.com/office/powerpoint/2015/09/main">
+    <mc:Choice Requires="p159">
       <p:transition xmlns:p14="http://schemas.microsoft.com/office/powerpoint/2010/main" spd="slow" p14:dur="2000">
         <p159:morph option="byObject"/>
       </p:transition>
     </mc:Choice>
-    <mc:Fallback>
+    <mc:Fallback xmlns="">
       <p:transition spd="slow">
         <p:fade/>
       </p:transition>
     </mc:Fallback>
   </mc:AlternateContent>
+  <p:timing>
+    <p:tnLst>
+      <p:par>
+        <p:cTn id="1" dur="indefinite" restart="never" nodeType="tmRoot">
+          <p:childTnLst>
+            <p:seq concurrent="1" nextAc="seek">
+              <p:cTn id="2" dur="indefinite" nodeType="mainSeq">
+                <p:childTnLst>
+                  <p:par>
+                    <p:cTn id="3" fill="hold">
+                      <p:stCondLst>
+                        <p:cond delay="indefinite"/>
+                        <p:cond evt="onBegin" delay="0">
+                          <p:tn val="2"/>
+                        </p:cond>
+                      </p:stCondLst>
+                      <p:childTnLst>
+                        <p:par>
+                          <p:cTn id="4" fill="hold">
+                            <p:stCondLst>
+                              <p:cond delay="0"/>
+                            </p:stCondLst>
+                            <p:childTnLst>
+                              <p:par>
+                                <p:cTn id="5" presetID="30" presetClass="emph" presetSubtype="0" fill="hold" grpId="0" nodeType="withEffect">
+                                  <p:stCondLst>
+                                    <p:cond delay="0"/>
+                                  </p:stCondLst>
+                                  <p:childTnLst>
+                                    <p:animClr clrSpc="hsl" dir="cw">
+                                      <p:cBhvr override="childStyle">
+                                        <p:cTn id="6" dur="500" fill="hold"/>
+                                        <p:tgtEl>
+                                          <p:spTgt spid="12"/>
+                                        </p:tgtEl>
+                                        <p:attrNameLst>
+                                          <p:attrName>style.color</p:attrName>
+                                        </p:attrNameLst>
+                                      </p:cBhvr>
+                                      <p:by>
+                                        <p:hsl h="0" s="12549" l="25098"/>
+                                      </p:by>
+                                    </p:animClr>
+                                    <p:animClr clrSpc="hsl" dir="cw">
+                                      <p:cBhvr>
+                                        <p:cTn id="7" dur="500" fill="hold"/>
+                                        <p:tgtEl>
+                                          <p:spTgt spid="12"/>
+                                        </p:tgtEl>
+                                        <p:attrNameLst>
+                                          <p:attrName>fillcolor</p:attrName>
+                                        </p:attrNameLst>
+                                      </p:cBhvr>
+                                      <p:by>
+                                        <p:hsl h="0" s="12549" l="25098"/>
+                                      </p:by>
+                                    </p:animClr>
+                                    <p:animClr clrSpc="hsl" dir="cw">
+                                      <p:cBhvr>
+                                        <p:cTn id="8" dur="500" fill="hold"/>
+                                        <p:tgtEl>
+                                          <p:spTgt spid="12"/>
+                                        </p:tgtEl>
+                                        <p:attrNameLst>
+                                          <p:attrName>stroke.color</p:attrName>
+                                        </p:attrNameLst>
+                                      </p:cBhvr>
+                                      <p:by>
+                                        <p:hsl h="0" s="12549" l="25098"/>
+                                      </p:by>
+                                    </p:animClr>
+                                    <p:set>
+                                      <p:cBhvr>
+                                        <p:cTn id="9" dur="500" fill="hold"/>
+                                        <p:tgtEl>
+                                          <p:spTgt spid="12"/>
+                                        </p:tgtEl>
+                                        <p:attrNameLst>
+                                          <p:attrName>fill.type</p:attrName>
+                                        </p:attrNameLst>
+                                      </p:cBhvr>
+                                      <p:to>
+                                        <p:strVal val="solid"/>
+                                      </p:to>
+                                    </p:set>
+                                  </p:childTnLst>
+                                </p:cTn>
+                              </p:par>
+                              <p:par>
+                                <p:cTn id="10" presetID="30" presetClass="emph" presetSubtype="0" fill="hold" grpId="0" nodeType="withEffect">
+                                  <p:stCondLst>
+                                    <p:cond delay="0"/>
+                                  </p:stCondLst>
+                                  <p:childTnLst>
+                                    <p:animClr clrSpc="hsl" dir="cw">
+                                      <p:cBhvr override="childStyle">
+                                        <p:cTn id="11" dur="500" fill="hold"/>
+                                        <p:tgtEl>
+                                          <p:spTgt spid="13"/>
+                                        </p:tgtEl>
+                                        <p:attrNameLst>
+                                          <p:attrName>style.color</p:attrName>
+                                        </p:attrNameLst>
+                                      </p:cBhvr>
+                                      <p:by>
+                                        <p:hsl h="0" s="12549" l="25098"/>
+                                      </p:by>
+                                    </p:animClr>
+                                    <p:animClr clrSpc="hsl" dir="cw">
+                                      <p:cBhvr>
+                                        <p:cTn id="12" dur="500" fill="hold"/>
+                                        <p:tgtEl>
+                                          <p:spTgt spid="13"/>
+                                        </p:tgtEl>
+                                        <p:attrNameLst>
+                                          <p:attrName>fillcolor</p:attrName>
+                                        </p:attrNameLst>
+                                      </p:cBhvr>
+                                      <p:by>
+                                        <p:hsl h="0" s="12549" l="25098"/>
+                                      </p:by>
+                                    </p:animClr>
+                                    <p:animClr clrSpc="hsl" dir="cw">
+                                      <p:cBhvr>
+                                        <p:cTn id="13" dur="500" fill="hold"/>
+                                        <p:tgtEl>
+                                          <p:spTgt spid="13"/>
+                                        </p:tgtEl>
+                                        <p:attrNameLst>
+                                          <p:attrName>stroke.color</p:attrName>
+                                        </p:attrNameLst>
+                                      </p:cBhvr>
+                                      <p:by>
+                                        <p:hsl h="0" s="12549" l="25098"/>
+                                      </p:by>
+                                    </p:animClr>
+                                    <p:set>
+                                      <p:cBhvr>
+                                        <p:cTn id="14" dur="500" fill="hold"/>
+                                        <p:tgtEl>
+                                          <p:spTgt spid="13"/>
+                                        </p:tgtEl>
+                                        <p:attrNameLst>
+                                          <p:attrName>fill.type</p:attrName>
+                                        </p:attrNameLst>
+                                      </p:cBhvr>
+                                      <p:to>
+                                        <p:strVal val="solid"/>
+                                      </p:to>
+                                    </p:set>
+                                  </p:childTnLst>
+                                </p:cTn>
+                              </p:par>
+                              <p:par>
+                                <p:cTn id="15" presetID="30" presetClass="emph" presetSubtype="0" fill="hold" grpId="0" nodeType="withEffect">
+                                  <p:stCondLst>
+                                    <p:cond delay="0"/>
+                                  </p:stCondLst>
+                                  <p:childTnLst>
+                                    <p:animClr clrSpc="hsl" dir="cw">
+                                      <p:cBhvr override="childStyle">
+                                        <p:cTn id="16" dur="500" fill="hold"/>
+                                        <p:tgtEl>
+                                          <p:spTgt spid="14"/>
+                                        </p:tgtEl>
+                                        <p:attrNameLst>
+                                          <p:attrName>style.color</p:attrName>
+                                        </p:attrNameLst>
+                                      </p:cBhvr>
+                                      <p:by>
+                                        <p:hsl h="0" s="12549" l="25098"/>
+                                      </p:by>
+                                    </p:animClr>
+                                    <p:animClr clrSpc="hsl" dir="cw">
+                                      <p:cBhvr>
+                                        <p:cTn id="17" dur="500" fill="hold"/>
+                                        <p:tgtEl>
+                                          <p:spTgt spid="14"/>
+                                        </p:tgtEl>
+                                        <p:attrNameLst>
+                                          <p:attrName>fillcolor</p:attrName>
+                                        </p:attrNameLst>
+                                      </p:cBhvr>
+                                      <p:by>
+                                        <p:hsl h="0" s="12549" l="25098"/>
+                                      </p:by>
+                                    </p:animClr>
+                                    <p:animClr clrSpc="hsl" dir="cw">
+                                      <p:cBhvr>
+                                        <p:cTn id="18" dur="500" fill="hold"/>
+                                        <p:tgtEl>
+                                          <p:spTgt spid="14"/>
+                                        </p:tgtEl>
+                                        <p:attrNameLst>
+                                          <p:attrName>stroke.color</p:attrName>
+                                        </p:attrNameLst>
+                                      </p:cBhvr>
+                                      <p:by>
+                                        <p:hsl h="0" s="12549" l="25098"/>
+                                      </p:by>
+                                    </p:animClr>
+                                    <p:set>
+                                      <p:cBhvr>
+                                        <p:cTn id="19" dur="500" fill="hold"/>
+                                        <p:tgtEl>
+                                          <p:spTgt spid="14"/>
+                                        </p:tgtEl>
+                                        <p:attrNameLst>
+                                          <p:attrName>fill.type</p:attrName>
+                                        </p:attrNameLst>
+                                      </p:cBhvr>
+                                      <p:to>
+                                        <p:strVal val="solid"/>
+                                      </p:to>
+                                    </p:set>
+                                  </p:childTnLst>
+                                </p:cTn>
+                              </p:par>
+                            </p:childTnLst>
+                          </p:cTn>
+                        </p:par>
+                      </p:childTnLst>
+                    </p:cTn>
+                  </p:par>
+                </p:childTnLst>
+              </p:cTn>
+              <p:prevCondLst>
+                <p:cond evt="onPrev" delay="0">
+                  <p:tgtEl>
+                    <p:sldTgt/>
+                  </p:tgtEl>
+                </p:cond>
+              </p:prevCondLst>
+              <p:nextCondLst>
+                <p:cond evt="onNext" delay="0">
+                  <p:tgtEl>
+                    <p:sldTgt/>
+                  </p:tgtEl>
+                </p:cond>
+              </p:nextCondLst>
+            </p:seq>
+          </p:childTnLst>
+        </p:cTn>
+      </p:par>
+    </p:tnLst>
+    <p:bldLst>
+      <p:bldP spid="12" grpId="0"/>
+      <p:bldP spid="13" grpId="0"/>
+      <p:bldP spid="14" grpId="0"/>
+    </p:bldLst>
+  </p:timing>
 </p:sld>
 </file>
 
@@ -4712,13 +4963,13 @@
   <p:clrMapOvr>
     <a:masterClrMapping/>
   </p:clrMapOvr>
-  <mc:AlternateContent xmlns:mc="http://schemas.openxmlformats.org/markup-compatibility/2006">
-    <mc:Choice xmlns:p159="http://schemas.microsoft.com/office/powerpoint/2015/09/main" Requires="p159">
+  <mc:AlternateContent xmlns:mc="http://schemas.openxmlformats.org/markup-compatibility/2006" xmlns:p159="http://schemas.microsoft.com/office/powerpoint/2015/09/main">
+    <mc:Choice Requires="p159">
       <p:transition xmlns:p14="http://schemas.microsoft.com/office/powerpoint/2010/main" spd="slow" p14:dur="2000">
         <p159:morph option="byObject"/>
       </p:transition>
     </mc:Choice>
-    <mc:Fallback>
+    <mc:Fallback xmlns="">
       <p:transition spd="slow">
         <p:fade/>
       </p:transition>
@@ -6159,13 +6410,13 @@
   <p:clrMapOvr>
     <a:masterClrMapping/>
   </p:clrMapOvr>
-  <mc:AlternateContent xmlns:mc="http://schemas.openxmlformats.org/markup-compatibility/2006">
-    <mc:Choice xmlns:p159="http://schemas.microsoft.com/office/powerpoint/2015/09/main" Requires="p159">
+  <mc:AlternateContent xmlns:mc="http://schemas.openxmlformats.org/markup-compatibility/2006" xmlns:p159="http://schemas.microsoft.com/office/powerpoint/2015/09/main">
+    <mc:Choice Requires="p159">
       <p:transition xmlns:p14="http://schemas.microsoft.com/office/powerpoint/2010/main" spd="slow" p14:dur="2000">
         <p159:morph option="byObject"/>
       </p:transition>
     </mc:Choice>
-    <mc:Fallback>
+    <mc:Fallback xmlns="">
       <p:transition spd="slow">
         <p:fade/>
       </p:transition>
@@ -8067,13 +8318,13 @@
   <p:clrMapOvr>
     <a:masterClrMapping/>
   </p:clrMapOvr>
-  <mc:AlternateContent xmlns:mc="http://schemas.openxmlformats.org/markup-compatibility/2006">
-    <mc:Choice xmlns:p159="http://schemas.microsoft.com/office/powerpoint/2015/09/main" Requires="p159">
+  <mc:AlternateContent xmlns:mc="http://schemas.openxmlformats.org/markup-compatibility/2006" xmlns:p159="http://schemas.microsoft.com/office/powerpoint/2015/09/main">
+    <mc:Choice Requires="p159">
       <p:transition xmlns:p14="http://schemas.microsoft.com/office/powerpoint/2010/main" spd="slow" p14:dur="2000">
         <p159:morph option="byObject"/>
       </p:transition>
     </mc:Choice>
-    <mc:Fallback>
+    <mc:Fallback xmlns="">
       <p:transition spd="slow">
         <p:fade/>
       </p:transition>
@@ -9690,13 +9941,13 @@
   <p:clrMapOvr>
     <a:masterClrMapping/>
   </p:clrMapOvr>
-  <mc:AlternateContent xmlns:mc="http://schemas.openxmlformats.org/markup-compatibility/2006">
-    <mc:Choice xmlns:p159="http://schemas.microsoft.com/office/powerpoint/2015/09/main" Requires="p159">
+  <mc:AlternateContent xmlns:mc="http://schemas.openxmlformats.org/markup-compatibility/2006" xmlns:p159="http://schemas.microsoft.com/office/powerpoint/2015/09/main">
+    <mc:Choice Requires="p159">
       <p:transition xmlns:p14="http://schemas.microsoft.com/office/powerpoint/2010/main" spd="slow" p14:dur="2000">
         <p159:morph option="byObject"/>
       </p:transition>
     </mc:Choice>
-    <mc:Fallback>
+    <mc:Fallback xmlns="">
       <p:transition spd="slow">
         <p:fade/>
       </p:transition>
@@ -11281,13 +11532,13 @@
   <p:clrMapOvr>
     <a:masterClrMapping/>
   </p:clrMapOvr>
-  <mc:AlternateContent xmlns:mc="http://schemas.openxmlformats.org/markup-compatibility/2006">
-    <mc:Choice xmlns:p159="http://schemas.microsoft.com/office/powerpoint/2015/09/main" Requires="p159">
+  <mc:AlternateContent xmlns:mc="http://schemas.openxmlformats.org/markup-compatibility/2006" xmlns:p159="http://schemas.microsoft.com/office/powerpoint/2015/09/main">
+    <mc:Choice Requires="p159">
       <p:transition xmlns:p14="http://schemas.microsoft.com/office/powerpoint/2010/main" spd="slow" p14:dur="2000">
         <p159:morph option="byObject"/>
       </p:transition>
     </mc:Choice>
-    <mc:Fallback>
+    <mc:Fallback xmlns="">
       <p:transition spd="slow">
         <p:fade/>
       </p:transition>
@@ -12134,13 +12385,13 @@
   <p:clrMapOvr>
     <a:masterClrMapping/>
   </p:clrMapOvr>
-  <mc:AlternateContent xmlns:mc="http://schemas.openxmlformats.org/markup-compatibility/2006">
-    <mc:Choice xmlns:p159="http://schemas.microsoft.com/office/powerpoint/2015/09/main" Requires="p159">
+  <mc:AlternateContent xmlns:mc="http://schemas.openxmlformats.org/markup-compatibility/2006" xmlns:p159="http://schemas.microsoft.com/office/powerpoint/2015/09/main">
+    <mc:Choice Requires="p159">
       <p:transition xmlns:p14="http://schemas.microsoft.com/office/powerpoint/2010/main" spd="slow" p14:dur="2000">
         <p159:morph option="byObject"/>
       </p:transition>
     </mc:Choice>
-    <mc:Fallback>
+    <mc:Fallback xmlns="">
       <p:transition spd="slow">
         <p:fade/>
       </p:transition>
@@ -13175,13 +13426,13 @@
   <p:clrMapOvr>
     <a:masterClrMapping/>
   </p:clrMapOvr>
-  <mc:AlternateContent xmlns:mc="http://schemas.openxmlformats.org/markup-compatibility/2006">
-    <mc:Choice xmlns:p159="http://schemas.microsoft.com/office/powerpoint/2015/09/main" Requires="p159">
+  <mc:AlternateContent xmlns:mc="http://schemas.openxmlformats.org/markup-compatibility/2006" xmlns:p159="http://schemas.microsoft.com/office/powerpoint/2015/09/main">
+    <mc:Choice Requires="p159">
       <p:transition xmlns:p14="http://schemas.microsoft.com/office/powerpoint/2010/main" spd="slow" p14:dur="2000">
         <p159:morph option="byObject"/>
       </p:transition>
     </mc:Choice>
-    <mc:Fallback>
+    <mc:Fallback xmlns="">
       <p:transition spd="slow">
         <p:fade/>
       </p:transition>
@@ -14453,13 +14704,13 @@
   <p:clrMapOvr>
     <a:masterClrMapping/>
   </p:clrMapOvr>
-  <mc:AlternateContent xmlns:mc="http://schemas.openxmlformats.org/markup-compatibility/2006">
-    <mc:Choice xmlns:p159="http://schemas.microsoft.com/office/powerpoint/2015/09/main" Requires="p159">
+  <mc:AlternateContent xmlns:mc="http://schemas.openxmlformats.org/markup-compatibility/2006" xmlns:p159="http://schemas.microsoft.com/office/powerpoint/2015/09/main">
+    <mc:Choice Requires="p159">
       <p:transition xmlns:p14="http://schemas.microsoft.com/office/powerpoint/2010/main" spd="slow" p14:dur="2000">
         <p159:morph option="byObject"/>
       </p:transition>
     </mc:Choice>
-    <mc:Fallback>
+    <mc:Fallback xmlns="">
       <p:transition spd="slow">
         <p:fade/>
       </p:transition>
@@ -15677,13 +15928,13 @@
   <p:clrMapOvr>
     <a:masterClrMapping/>
   </p:clrMapOvr>
-  <mc:AlternateContent xmlns:mc="http://schemas.openxmlformats.org/markup-compatibility/2006">
-    <mc:Choice xmlns:p159="http://schemas.microsoft.com/office/powerpoint/2015/09/main" Requires="p159">
+  <mc:AlternateContent xmlns:mc="http://schemas.openxmlformats.org/markup-compatibility/2006" xmlns:p159="http://schemas.microsoft.com/office/powerpoint/2015/09/main">
+    <mc:Choice Requires="p159">
       <p:transition xmlns:p14="http://schemas.microsoft.com/office/powerpoint/2010/main" spd="slow" p14:dur="2000">
         <p159:morph option="byObject"/>
       </p:transition>
     </mc:Choice>
-    <mc:Fallback>
+    <mc:Fallback xmlns="">
       <p:transition spd="slow">
         <p:fade/>
       </p:transition>
@@ -16977,13 +17228,13 @@
   <p:clrMapOvr>
     <a:masterClrMapping/>
   </p:clrMapOvr>
-  <mc:AlternateContent xmlns:mc="http://schemas.openxmlformats.org/markup-compatibility/2006">
-    <mc:Choice xmlns:p159="http://schemas.microsoft.com/office/powerpoint/2015/09/main" Requires="p159">
+  <mc:AlternateContent xmlns:mc="http://schemas.openxmlformats.org/markup-compatibility/2006" xmlns:p159="http://schemas.microsoft.com/office/powerpoint/2015/09/main">
+    <mc:Choice Requires="p159">
       <p:transition xmlns:p14="http://schemas.microsoft.com/office/powerpoint/2010/main" spd="slow" p14:dur="2000">
         <p159:morph option="byObject"/>
       </p:transition>
     </mc:Choice>
-    <mc:Fallback>
+    <mc:Fallback xmlns="">
       <p:transition spd="slow">
         <p:fade/>
       </p:transition>
@@ -18735,13 +18986,13 @@
   <p:clrMapOvr>
     <a:masterClrMapping/>
   </p:clrMapOvr>
-  <mc:AlternateContent xmlns:mc="http://schemas.openxmlformats.org/markup-compatibility/2006">
-    <mc:Choice xmlns:p159="http://schemas.microsoft.com/office/powerpoint/2015/09/main" Requires="p159">
+  <mc:AlternateContent xmlns:mc="http://schemas.openxmlformats.org/markup-compatibility/2006" xmlns:p159="http://schemas.microsoft.com/office/powerpoint/2015/09/main">
+    <mc:Choice Requires="p159">
       <p:transition xmlns:p14="http://schemas.microsoft.com/office/powerpoint/2010/main" spd="slow" p14:dur="2000">
         <p159:morph option="byObject"/>
       </p:transition>
     </mc:Choice>
-    <mc:Fallback>
+    <mc:Fallback xmlns="">
       <p:transition spd="slow">
         <p:fade/>
       </p:transition>
@@ -20168,13 +20419,13 @@
   <p:clrMapOvr>
     <a:masterClrMapping/>
   </p:clrMapOvr>
-  <mc:AlternateContent xmlns:mc="http://schemas.openxmlformats.org/markup-compatibility/2006">
-    <mc:Choice xmlns:p159="http://schemas.microsoft.com/office/powerpoint/2015/09/main" Requires="p159">
+  <mc:AlternateContent xmlns:mc="http://schemas.openxmlformats.org/markup-compatibility/2006" xmlns:p159="http://schemas.microsoft.com/office/powerpoint/2015/09/main">
+    <mc:Choice Requires="p159">
       <p:transition xmlns:p14="http://schemas.microsoft.com/office/powerpoint/2010/main" spd="slow" p14:dur="2000">
         <p159:morph option="byObject"/>
       </p:transition>
     </mc:Choice>
-    <mc:Fallback>
+    <mc:Fallback xmlns="">
       <p:transition spd="slow">
         <p:fade/>
       </p:transition>
@@ -21177,13 +21428,13 @@
   <p:clrMapOvr>
     <a:masterClrMapping/>
   </p:clrMapOvr>
-  <mc:AlternateContent xmlns:mc="http://schemas.openxmlformats.org/markup-compatibility/2006">
-    <mc:Choice xmlns:p159="http://schemas.microsoft.com/office/powerpoint/2015/09/main" Requires="p159">
+  <mc:AlternateContent xmlns:mc="http://schemas.openxmlformats.org/markup-compatibility/2006" xmlns:p159="http://schemas.microsoft.com/office/powerpoint/2015/09/main">
+    <mc:Choice Requires="p159">
       <p:transition xmlns:p14="http://schemas.microsoft.com/office/powerpoint/2010/main" spd="slow" p14:dur="2000">
         <p159:morph option="byObject"/>
       </p:transition>
     </mc:Choice>
-    <mc:Fallback>
+    <mc:Fallback xmlns="">
       <p:transition spd="slow">
         <p:fade/>
       </p:transition>
@@ -22429,13 +22680,13 @@
   <p:clrMapOvr>
     <a:masterClrMapping/>
   </p:clrMapOvr>
-  <mc:AlternateContent xmlns:mc="http://schemas.openxmlformats.org/markup-compatibility/2006">
-    <mc:Choice xmlns:p159="http://schemas.microsoft.com/office/powerpoint/2015/09/main" Requires="p159">
+  <mc:AlternateContent xmlns:mc="http://schemas.openxmlformats.org/markup-compatibility/2006" xmlns:p159="http://schemas.microsoft.com/office/powerpoint/2015/09/main">
+    <mc:Choice Requires="p159">
       <p:transition xmlns:p14="http://schemas.microsoft.com/office/powerpoint/2010/main" spd="slow" p14:dur="2000">
         <p159:morph option="byObject"/>
       </p:transition>
     </mc:Choice>
-    <mc:Fallback>
+    <mc:Fallback xmlns="">
       <p:transition spd="slow">
         <p:fade/>
       </p:transition>

</xml_diff>